<commit_message>
docs: current test counts, live link and landing page in the deck
The deck shows the landing page and the live address, and its closing wording no longer assumes
a demo. Test counts are 674 backend and 425 frontend (the captured pytest run showed 656).
</commit_message>
<xml_diff>
--- a/StudAura-presentation.pptx
+++ b/StudAura-presentation.pptx
@@ -2157,7 +2157,7 @@
         </p:nvSpPr>
         <p:spPr>
           <a:xfrm>
-            <a:off x="640080" y="3886200"/>
+            <a:off x="640080" y="3703320"/>
             <a:ext cx="7863840" cy="365760"/>
           </a:xfrm>
           <a:prstGeom prst="rect">
@@ -2191,6 +2191,45 @@
       <p:sp>
         <p:nvSpPr>
           <p:cNvPr id="6" name="Text 4"/>
+          <p:cNvSpPr txBox="1"/>
+          <p:nvPr/>
+        </p:nvSpPr>
+        <p:spPr>
+          <a:xfrm>
+            <a:off x="640080" y="4114800"/>
+            <a:ext cx="7863840" cy="274320"/>
+          </a:xfrm>
+          <a:prstGeom prst="rect">
+            <a:avLst/>
+          </a:prstGeom>
+          <a:noFill/>
+          <a:ln/>
+        </p:spPr>
+        <p:txBody>
+          <a:bodyPr wrap="square" lIns="0" tIns="0" rIns="0" bIns="0" rtlCol="0" anchor="ctr"/>
+          <a:lstStyle/>
+          <a:p>
+            <a:pPr indent="0" marL="0">
+              <a:buNone/>
+            </a:pPr>
+            <a:r>
+              <a:rPr lang="en-US" sz="1400" b="1" dirty="0">
+                <a:solidFill>
+                  <a:srgbClr val="F21D3D"/>
+                </a:solidFill>
+                <a:latin typeface="Calibri" pitchFamily="34" charset="0"/>
+                <a:ea typeface="Calibri" pitchFamily="34" charset="-122"/>
+                <a:cs typeface="Calibri" pitchFamily="34" charset="-120"/>
+              </a:rPr>
+              <a:t>Live app: stud-aura.vercel.app</a:t>
+            </a:r>
+            <a:endParaRPr lang="en-US" sz="1400" dirty="0"/>
+          </a:p>
+        </p:txBody>
+      </p:sp>
+      <p:sp>
+        <p:nvSpPr>
+          <p:cNvPr id="7" name="Text 5"/>
           <p:cNvSpPr txBox="1"/>
           <p:nvPr/>
         </p:nvSpPr>
@@ -3955,7 +3994,7 @@
                 <a:ea typeface="Calibri" pitchFamily="34" charset="-122"/>
                 <a:cs typeface="Calibri" pitchFamily="34" charset="-120"/>
               </a:rPr>
-              <a:t>656</a:t>
+              <a:t>674</a:t>
             </a:r>
             <a:endParaRPr lang="en-US" sz="4000" dirty="0"/>
           </a:p>
@@ -4060,7 +4099,7 @@
                 <a:ea typeface="Calibri" pitchFamily="34" charset="-122"/>
                 <a:cs typeface="Calibri" pitchFamily="34" charset="-120"/>
               </a:rPr>
-              <a:t>371</a:t>
+              <a:t>425</a:t>
             </a:r>
             <a:endParaRPr lang="en-US" sz="4000" dirty="0"/>
           </a:p>
@@ -4165,7 +4204,7 @@
                 <a:ea typeface="Calibri" pitchFamily="34" charset="-122"/>
                 <a:cs typeface="Calibri" pitchFamily="34" charset="-120"/>
               </a:rPr>
-              <a:t>28</a:t>
+              <a:t>30+</a:t>
             </a:r>
             <a:endParaRPr lang="en-US" sz="4000" dirty="0"/>
           </a:p>
@@ -4296,7 +4335,7 @@
                 <a:ea typeface="Calibri" pitchFamily="34" charset="-122"/>
                 <a:cs typeface="Calibri" pitchFamily="34" charset="-120"/>
               </a:rPr>
-              <a:t>pytest -v: 656 passed</a:t>
+              <a:t>pytest -v on the evidence run: 656 passed; 674 now</a:t>
             </a:r>
             <a:endParaRPr lang="en-US" sz="1400" dirty="0"/>
           </a:p>
@@ -4742,7 +4781,7 @@
                 <a:ea typeface="Calibri" pitchFamily="34" charset="-122"/>
                 <a:cs typeface="Calibri" pitchFamily="34" charset="-120"/>
               </a:rPr>
-              <a:t>The cluster is destroyed after the demo to avoid cost.</a:t>
+              <a:t>The cluster is destroyed once the evidence is captured, to avoid cost.</a:t>
             </a:r>
             <a:endParaRPr lang="en-US" sz="1400" dirty="0"/>
           </a:p>
@@ -5266,7 +5305,7 @@
       </p:sp>
       <p:pic>
         <p:nvPicPr>
-          <p:cNvPr id="17" name="Image 0" descr="D:/Resume projects/StudAura/docs/screenshots/app-localhost-3000.png">    </p:cNvPr>
+          <p:cNvPr id="17" name="Image 0" descr="D:/Resume projects/StudAura/docs/screenshots/landing-hero.png">    </p:cNvPr>
           <p:cNvPicPr>
             <a:picLocks noChangeAspect="1"/>
           </p:cNvPicPr>
@@ -5321,7 +5360,7 @@
                 <a:ea typeface="Calibri" pitchFamily="34" charset="-122"/>
                 <a:cs typeface="Calibri" pitchFamily="34" charset="-120"/>
               </a:rPr>
-              <a:t>Docker Compose, localhost:3000</a:t>
+              <a:t>Landing page at stud-aura.vercel.app</a:t>
             </a:r>
             <a:endParaRPr lang="en-US" sz="1100" dirty="0"/>
           </a:p>
@@ -9157,7 +9196,7 @@
                 <a:ea typeface="Calibri" pitchFamily="34" charset="-122"/>
                 <a:cs typeface="Calibri" pitchFamily="34" charset="-120"/>
               </a:rPr>
-              <a:t>Destroyed after the demo so nothing keeps billing</a:t>
+              <a:t>Destroyed once the evidence was captured, so nothing keeps billing</a:t>
             </a:r>
             <a:endParaRPr lang="en-US" sz="1400" dirty="0"/>
           </a:p>

</xml_diff>